<commit_message>
Session 0+ 1 + 2
</commit_message>
<xml_diff>
--- a/Session0/Session0.pptx
+++ b/Session0/Session0.pptx
@@ -306,7 +306,7 @@
           <a:p>
             <a:fld id="{EEC665CA-D682-48EC-95D2-126FD6449D65}" type="datetime1">
               <a:rPr lang="de-CH" sz="900" smtClean="0"/>
-              <a:t>26.02.2026</a:t>
+              <a:t>27.02.2026</a:t>
             </a:fld>
             <a:endParaRPr lang="de-CH" sz="900"/>
           </a:p>
@@ -826,7 +826,7 @@
           <a:p>
             <a:fld id="{A17AAF7D-4283-4014-80F4-26E915FEACF8}" type="datetime1">
               <a:rPr lang="de-CH" smtClean="0"/>
-              <a:t>26.02.2026</a:t>
+              <a:t>27.02.2026</a:t>
             </a:fld>
             <a:endParaRPr lang="de-CH" dirty="0"/>
           </a:p>
@@ -1095,7 +1095,7 @@
           <a:p>
             <a:fld id="{C515E362-FD09-4668-88D0-DD938814C8D5}" type="datetime1">
               <a:rPr lang="en-GB" noProof="0" smtClean="0"/>
-              <a:t>26/02/2026</a:t>
+              <a:t>27/02/2026</a:t>
             </a:fld>
             <a:endParaRPr lang="en-GB" noProof="0" dirty="0"/>
           </a:p>
@@ -1452,7 +1452,7 @@
           <a:p>
             <a:fld id="{932DB27F-F071-4A95-9EEE-5C5CBF64EE26}" type="datetime1">
               <a:rPr lang="en-GB" noProof="0" smtClean="0"/>
-              <a:t>26/02/2026</a:t>
+              <a:t>27/02/2026</a:t>
             </a:fld>
             <a:endParaRPr lang="en-GB" noProof="0" dirty="0"/>
           </a:p>
@@ -1821,7 +1821,7 @@
           <a:p>
             <a:fld id="{D80781FC-1424-4209-8A6E-9A2144BB4E72}" type="datetime1">
               <a:rPr lang="en-GB" noProof="0" smtClean="0"/>
-              <a:t>26/02/2026</a:t>
+              <a:t>27/02/2026</a:t>
             </a:fld>
             <a:endParaRPr lang="en-GB" noProof="0" dirty="0"/>
           </a:p>
@@ -3201,7 +3201,7 @@
           <a:p>
             <a:fld id="{4F39C5B1-C2A0-4DDD-92D8-000840688964}" type="datetime1">
               <a:rPr lang="en-GB" noProof="0" smtClean="0"/>
-              <a:t>26/02/2026</a:t>
+              <a:t>27/02/2026</a:t>
             </a:fld>
             <a:endParaRPr lang="en-GB" noProof="0" dirty="0"/>
           </a:p>
@@ -3649,7 +3649,7 @@
           <a:p>
             <a:fld id="{6CDFE4C3-9C6E-4FD5-958F-990E93D47FB5}" type="datetime1">
               <a:rPr lang="en-GB" noProof="0" smtClean="0"/>
-              <a:t>26/02/2026</a:t>
+              <a:t>27/02/2026</a:t>
             </a:fld>
             <a:endParaRPr lang="en-GB" noProof="0" dirty="0"/>
           </a:p>
@@ -4525,7 +4525,7 @@
           <a:p>
             <a:fld id="{B5F690C5-E137-4007-8D4D-76228B1F67DB}" type="datetime1">
               <a:rPr lang="en-GB" noProof="0" smtClean="0"/>
-              <a:t>26/02/2026</a:t>
+              <a:t>27/02/2026</a:t>
             </a:fld>
             <a:endParaRPr lang="de-CH" noProof="0"/>
           </a:p>
@@ -4717,7 +4717,7 @@
           <a:p>
             <a:fld id="{7997AA47-EF2E-46FA-9B55-BB5AE14DC90C}" type="datetime1">
               <a:rPr lang="en-GB" noProof="0" smtClean="0"/>
-              <a:t>26/02/2026</a:t>
+              <a:t>27/02/2026</a:t>
             </a:fld>
             <a:endParaRPr lang="en-GB" noProof="0" dirty="0"/>
           </a:p>
@@ -4993,7 +4993,7 @@
           <a:p>
             <a:fld id="{B45A84FF-55FD-4307-A84C-1706BE180F7F}" type="datetime1">
               <a:rPr lang="en-GB" noProof="0" smtClean="0"/>
-              <a:t>26/02/2026</a:t>
+              <a:t>27/02/2026</a:t>
             </a:fld>
             <a:endParaRPr lang="en-GB" noProof="0" dirty="0"/>
           </a:p>
@@ -5526,7 +5526,7 @@
           <a:p>
             <a:fld id="{850507E7-22DC-4FF9-A96B-4B72D63E2C34}" type="datetime1">
               <a:rPr lang="en-GB" noProof="0" smtClean="0"/>
-              <a:t>26/02/2026</a:t>
+              <a:t>27/02/2026</a:t>
             </a:fld>
             <a:endParaRPr lang="en-GB" noProof="0" dirty="0"/>
           </a:p>
@@ -6083,7 +6083,7 @@
           <a:p>
             <a:fld id="{719E2C6A-27AF-44E0-BCA7-589AA25EC4BE}" type="datetime1">
               <a:rPr lang="en-GB" noProof="0" smtClean="0"/>
-              <a:t>26/02/2026</a:t>
+              <a:t>27/02/2026</a:t>
             </a:fld>
             <a:endParaRPr lang="de-CH" noProof="0"/>
           </a:p>
@@ -6375,7 +6375,7 @@
           <a:p>
             <a:fld id="{2D90BFC6-1E20-4BFB-AA94-CA2B6A0C001C}" type="datetime1">
               <a:rPr lang="en-GB" noProof="0" smtClean="0"/>
-              <a:t>26/02/2026</a:t>
+              <a:t>27/02/2026</a:t>
             </a:fld>
             <a:endParaRPr lang="en-GB" noProof="0" dirty="0"/>
           </a:p>
@@ -6916,7 +6916,7 @@
           <a:p>
             <a:fld id="{B7827833-B3EB-4D22-BDF4-3587D1185BAB}" type="datetime1">
               <a:rPr lang="en-GB" noProof="0" smtClean="0"/>
-              <a:t>26/02/2026</a:t>
+              <a:t>27/02/2026</a:t>
             </a:fld>
             <a:endParaRPr lang="en-GB" noProof="0" dirty="0"/>
           </a:p>
@@ -7254,7 +7254,7 @@
           <a:p>
             <a:fld id="{96B6F8EB-C510-46A4-AC06-3410590A9997}" type="datetime1">
               <a:rPr lang="en-GB" noProof="0" smtClean="0"/>
-              <a:t>26/02/2026</a:t>
+              <a:t>27/02/2026</a:t>
             </a:fld>
             <a:endParaRPr lang="en-GB" noProof="0" dirty="0"/>
           </a:p>
@@ -8078,7 +8078,7 @@
           <a:p>
             <a:fld id="{BE30AAB7-925B-4FF0-9C4C-ED84A2794D7B}" type="datetime1">
               <a:rPr lang="en-GB" noProof="0" smtClean="0"/>
-              <a:t>26/02/2026</a:t>
+              <a:t>27/02/2026</a:t>
             </a:fld>
             <a:endParaRPr lang="en-GB" noProof="0" dirty="0"/>
           </a:p>
@@ -8862,7 +8862,7 @@
           <a:p>
             <a:fld id="{B4C6DD47-B5A0-4950-A19A-43F01AC30E13}" type="datetime1">
               <a:rPr lang="en-GB" noProof="0" smtClean="0"/>
-              <a:t>26/02/2026</a:t>
+              <a:t>27/02/2026</a:t>
             </a:fld>
             <a:endParaRPr lang="en-GB" noProof="0" dirty="0"/>
           </a:p>
@@ -9566,7 +9566,7 @@
           <a:p>
             <a:fld id="{99F7C6AB-D72C-4DB2-B412-E0727C77E8DE}" type="datetime1">
               <a:rPr lang="en-GB" noProof="0" smtClean="0"/>
-              <a:t>26/02/2026</a:t>
+              <a:t>27/02/2026</a:t>
             </a:fld>
             <a:endParaRPr lang="en-GB" noProof="0" dirty="0"/>
           </a:p>
@@ -9956,7 +9956,7 @@
           <a:p>
             <a:fld id="{43608F40-4162-43B2-8892-FE05E38730A8}" type="datetime1">
               <a:rPr lang="en-GB" noProof="0" smtClean="0"/>
-              <a:t>26/02/2026</a:t>
+              <a:t>27/02/2026</a:t>
             </a:fld>
             <a:endParaRPr lang="en-GB" noProof="0" dirty="0"/>
           </a:p>
@@ -10536,7 +10536,7 @@
           <a:p>
             <a:fld id="{171122E3-8667-4CBC-89DA-665A2A12A766}" type="datetime1">
               <a:rPr lang="en-GB" noProof="0" smtClean="0"/>
-              <a:t>26/02/2026</a:t>
+              <a:t>27/02/2026</a:t>
             </a:fld>
             <a:endParaRPr lang="en-GB" noProof="0" dirty="0"/>
           </a:p>
@@ -11351,7 +11351,7 @@
           <a:p>
             <a:fld id="{4AB1CAA3-0E26-4D77-9861-DAEB699CEE1D}" type="datetime1">
               <a:rPr lang="en-GB" noProof="0" smtClean="0"/>
-              <a:t>26/02/2026</a:t>
+              <a:t>27/02/2026</a:t>
             </a:fld>
             <a:endParaRPr lang="en-GB" noProof="0" dirty="0"/>
           </a:p>
@@ -12454,7 +12454,7 @@
           <a:p>
             <a:fld id="{8416D8B0-C1F6-401E-A49C-9F8317A00928}" type="datetime1">
               <a:rPr lang="en-GB" noProof="0" smtClean="0"/>
-              <a:t>26/02/2026</a:t>
+              <a:t>27/02/2026</a:t>
             </a:fld>
             <a:endParaRPr lang="en-GB" noProof="0" dirty="0"/>
           </a:p>
@@ -13529,7 +13529,7 @@
           <a:p>
             <a:fld id="{9B253AD7-DD44-4CC1-898B-5978DEB5542A}" type="datetime1">
               <a:rPr lang="en-GB" noProof="0" smtClean="0"/>
-              <a:t>26/02/2026</a:t>
+              <a:t>27/02/2026</a:t>
             </a:fld>
             <a:endParaRPr lang="en-GB" noProof="0" dirty="0"/>
           </a:p>
@@ -15573,7 +15573,7 @@
           <a:p>
             <a:fld id="{C28D30C8-24DA-4554-A89F-E5537E310C1A}" type="datetime1">
               <a:rPr lang="en-GB" noProof="0" smtClean="0"/>
-              <a:t>26/02/2026</a:t>
+              <a:t>27/02/2026</a:t>
             </a:fld>
             <a:endParaRPr lang="en-GB" noProof="0" dirty="0"/>
           </a:p>
@@ -17627,7 +17627,7 @@
           <a:p>
             <a:fld id="{F8C16490-B6B0-45CE-820B-001EE801F293}" type="datetime1">
               <a:rPr lang="en-GB" noProof="0" smtClean="0"/>
-              <a:t>26/02/2026</a:t>
+              <a:t>27/02/2026</a:t>
             </a:fld>
             <a:endParaRPr lang="en-GB" noProof="0" dirty="0"/>
           </a:p>
@@ -18217,7 +18217,7 @@
           <a:p>
             <a:fld id="{F65019D3-7194-40B8-AC7F-62CE5FB72B83}" type="datetime1">
               <a:rPr lang="en-GB" noProof="0" smtClean="0"/>
-              <a:t>26/02/2026</a:t>
+              <a:t>27/02/2026</a:t>
             </a:fld>
             <a:endParaRPr lang="de-CH" noProof="0"/>
           </a:p>
@@ -18396,7 +18396,7 @@
           <a:p>
             <a:fld id="{003B95B4-305B-416A-97B6-6B425E07ADA1}" type="datetime1">
               <a:rPr lang="en-GB" noProof="0" smtClean="0"/>
-              <a:t>26/02/2026</a:t>
+              <a:t>27/02/2026</a:t>
             </a:fld>
             <a:r>
               <a:rPr lang="en-GB" noProof="0"/>
@@ -19948,7 +19948,7 @@
           <a:p>
             <a:fld id="{103A9771-FEDF-4EB5-8B31-317E659CFCEB}" type="datetime1">
               <a:rPr lang="en-GB" noProof="0" smtClean="0"/>
-              <a:t>26/02/2026</a:t>
+              <a:t>27/02/2026</a:t>
             </a:fld>
             <a:endParaRPr lang="en-GB" noProof="0" dirty="0"/>
           </a:p>
@@ -20706,7 +20706,7 @@
           <a:p>
             <a:fld id="{61691FF8-B7CE-4EC3-A346-E51C1211B498}" type="datetime1">
               <a:rPr lang="en-GB" noProof="0" smtClean="0"/>
-              <a:t>26/02/2026</a:t>
+              <a:t>27/02/2026</a:t>
             </a:fld>
             <a:endParaRPr lang="en-GB" noProof="0" dirty="0"/>
           </a:p>
@@ -21070,7 +21070,7 @@
           <a:p>
             <a:fld id="{F511CE76-746B-4D58-8B44-9105BE8285E3}" type="datetime1">
               <a:rPr lang="en-GB" noProof="0" smtClean="0"/>
-              <a:t>26/02/2026</a:t>
+              <a:t>27/02/2026</a:t>
             </a:fld>
             <a:endParaRPr lang="en-GB" noProof="0" dirty="0"/>
           </a:p>
@@ -21188,7 +21188,7 @@
           <a:p>
             <a:fld id="{37761F74-EB35-4861-A493-181201845457}" type="datetime1">
               <a:rPr lang="en-GB" noProof="0" smtClean="0"/>
-              <a:t>26/02/2026</a:t>
+              <a:t>27/02/2026</a:t>
             </a:fld>
             <a:endParaRPr lang="en-GB" noProof="0" dirty="0"/>
           </a:p>
@@ -21354,7 +21354,7 @@
           <a:p>
             <a:fld id="{39B43C91-F0D8-4D10-AD7C-80106A87C29F}" type="datetime1">
               <a:rPr lang="en-GB" noProof="0" smtClean="0"/>
-              <a:t>26/02/2026</a:t>
+              <a:t>27/02/2026</a:t>
             </a:fld>
             <a:endParaRPr lang="en-GB" noProof="0" dirty="0"/>
           </a:p>
@@ -21637,7 +21637,7 @@
           <a:p>
             <a:fld id="{C3D20089-3297-4BE2-B75D-7802F1A971AD}" type="datetime1">
               <a:rPr lang="en-GB" noProof="0" smtClean="0"/>
-              <a:t>26/02/2026</a:t>
+              <a:t>27/02/2026</a:t>
             </a:fld>
             <a:endParaRPr lang="en-GB" noProof="0" dirty="0"/>
           </a:p>
@@ -21958,7 +21958,7 @@
           <a:p>
             <a:fld id="{AE965245-EA34-4D3A-B244-6B1F8D9D1BFC}" type="datetime1">
               <a:rPr lang="en-GB" smtClean="0"/>
-              <a:t>26/02/2026</a:t>
+              <a:t>27/02/2026</a:t>
             </a:fld>
             <a:endParaRPr lang="de-CH" dirty="0"/>
           </a:p>
@@ -22211,7 +22211,7 @@
           <a:p>
             <a:fld id="{2BB46893-FD8B-47A3-B1A8-FB4C75AB05E7}" type="datetime1">
               <a:rPr lang="en-GB" noProof="0" smtClean="0"/>
-              <a:t>26/02/2026</a:t>
+              <a:t>27/02/2026</a:t>
             </a:fld>
             <a:endParaRPr lang="en-GB" noProof="0" dirty="0"/>
           </a:p>
@@ -22484,7 +22484,7 @@
           <a:p>
             <a:fld id="{9A217B6A-5CC5-4D65-8051-2CD5B188935C}" type="datetime1">
               <a:rPr lang="en-GB" noProof="0" smtClean="0"/>
-              <a:t>26/02/2026</a:t>
+              <a:t>27/02/2026</a:t>
             </a:fld>
             <a:endParaRPr lang="en-GB" noProof="0" dirty="0"/>
           </a:p>
@@ -22705,7 +22705,7 @@
           <a:p>
             <a:fld id="{B906751F-4954-4452-BFF4-12ED94DF4FA2}" type="datetime1">
               <a:rPr lang="en-GB" noProof="0" smtClean="0"/>
-              <a:t>26/02/2026</a:t>
+              <a:t>27/02/2026</a:t>
             </a:fld>
             <a:endParaRPr lang="en-GB" noProof="0" dirty="0"/>
           </a:p>
@@ -23065,7 +23065,7 @@
           <a:p>
             <a:fld id="{ACFC5840-8FE0-42F7-AFBC-7CEE90AF5A88}" type="datetime1">
               <a:rPr lang="en-GB" noProof="0" smtClean="0"/>
-              <a:t>26/02/2026</a:t>
+              <a:t>27/02/2026</a:t>
             </a:fld>
             <a:endParaRPr lang="en-GB" noProof="0" dirty="0"/>
           </a:p>
@@ -24091,8 +24091,8 @@
           </a:p>
         </p:txBody>
       </p:sp>
-      <mc:AlternateContent xmlns:mc="http://schemas.openxmlformats.org/markup-compatibility/2006">
-        <mc:Choice xmlns:p14="http://schemas.microsoft.com/office/powerpoint/2010/main" Requires="p14">
+      <mc:AlternateContent xmlns:mc="http://schemas.openxmlformats.org/markup-compatibility/2006" xmlns:p14="http://schemas.microsoft.com/office/powerpoint/2010/main">
+        <mc:Choice Requires="p14">
           <p:contentPart p14:bwMode="auto" r:id="rId2">
             <p14:nvContentPartPr>
               <p14:cNvPr id="11" name="Ink 10">
@@ -24111,7 +24111,7 @@
             </p14:xfrm>
           </p:contentPart>
         </mc:Choice>
-        <mc:Fallback>
+        <mc:Fallback xmlns="">
           <p:pic>
             <p:nvPicPr>
               <p:cNvPr id="11" name="Ink 10">
@@ -24275,7 +24275,7 @@
             <p:ph idx="1"/>
             <p:extLst>
               <p:ext uri="{D42A27DB-BD31-4B8C-83A1-F6EECF244321}">
-                <p14:modId xmlns:p14="http://schemas.microsoft.com/office/powerpoint/2010/main" val="794050286"/>
+                <p14:modId xmlns:p14="http://schemas.microsoft.com/office/powerpoint/2010/main" val="3310141573"/>
               </p:ext>
             </p:extLst>
           </p:nvPr>
@@ -24599,7 +24599,7 @@
                     <a:p>
                       <a:r>
                         <a:rPr lang="en-US" dirty="0"/>
-                        <a:t>10. Apr</a:t>
+                        <a:t>17. Apr</a:t>
                       </a:r>
                       <a:endParaRPr lang="en-CH" dirty="0"/>
                     </a:p>
@@ -24638,7 +24638,7 @@
                     <a:p>
                       <a:r>
                         <a:rPr lang="en-US" dirty="0"/>
-                        <a:t>17. Apr</a:t>
+                        <a:t>24. Apr</a:t>
                       </a:r>
                       <a:endParaRPr lang="en-CH" dirty="0"/>
                     </a:p>
@@ -24682,7 +24682,7 @@
                             <a:srgbClr val="FF0000"/>
                           </a:solidFill>
                         </a:rPr>
-                        <a:t>24. Apr</a:t>
+                        <a:t>01. May</a:t>
                       </a:r>
                       <a:endParaRPr lang="en-CH" dirty="0">
                         <a:solidFill>
@@ -24733,7 +24733,7 @@
                       </a:pPr>
                       <a:r>
                         <a:rPr lang="en-US" dirty="0"/>
-                        <a:t>01. May</a:t>
+                        <a:t>08. May</a:t>
                       </a:r>
                       <a:endParaRPr lang="en-CH" dirty="0"/>
                     </a:p>
@@ -24772,7 +24772,7 @@
                     <a:p>
                       <a:r>
                         <a:rPr lang="en-US" dirty="0"/>
-                        <a:t>08. May</a:t>
+                        <a:t>15. May</a:t>
                       </a:r>
                       <a:endParaRPr lang="en-CH" dirty="0"/>
                     </a:p>
@@ -24811,7 +24811,7 @@
                     <a:p>
                       <a:r>
                         <a:rPr lang="en-US" dirty="0"/>
-                        <a:t>15. May</a:t>
+                        <a:t>22. May</a:t>
                       </a:r>
                       <a:endParaRPr lang="en-CH" dirty="0"/>
                     </a:p>
@@ -24849,8 +24849,12 @@
                     <a:lstStyle/>
                     <a:p>
                       <a:r>
+                        <a:rPr lang="en-US"/>
+                        <a:t>29. </a:t>
+                      </a:r>
+                      <a:r>
                         <a:rPr lang="en-US" dirty="0"/>
-                        <a:t>22. May</a:t>
+                        <a:t>May</a:t>
                       </a:r>
                       <a:endParaRPr lang="en-CH" dirty="0"/>
                     </a:p>
@@ -25928,8 +25932,8 @@
           </a:prstGeom>
         </p:spPr>
       </p:pic>
-      <mc:AlternateContent xmlns:mc="http://schemas.openxmlformats.org/markup-compatibility/2006">
-        <mc:Choice xmlns:p14="http://schemas.microsoft.com/office/powerpoint/2010/main" Requires="p14">
+      <mc:AlternateContent xmlns:mc="http://schemas.openxmlformats.org/markup-compatibility/2006" xmlns:p14="http://schemas.microsoft.com/office/powerpoint/2010/main">
+        <mc:Choice Requires="p14">
           <p:contentPart p14:bwMode="auto" r:id="rId4">
             <p14:nvContentPartPr>
               <p14:cNvPr id="11" name="Ink 10">
@@ -25948,7 +25952,7 @@
             </p14:xfrm>
           </p:contentPart>
         </mc:Choice>
-        <mc:Fallback>
+        <mc:Fallback xmlns="">
           <p:pic>
             <p:nvPicPr>
               <p:cNvPr id="11" name="Ink 10">
@@ -25979,8 +25983,8 @@
           </p:pic>
         </mc:Fallback>
       </mc:AlternateContent>
-      <mc:AlternateContent xmlns:mc="http://schemas.openxmlformats.org/markup-compatibility/2006">
-        <mc:Choice xmlns:p14="http://schemas.microsoft.com/office/powerpoint/2010/main" Requires="p14">
+      <mc:AlternateContent xmlns:mc="http://schemas.openxmlformats.org/markup-compatibility/2006" xmlns:p14="http://schemas.microsoft.com/office/powerpoint/2010/main">
+        <mc:Choice Requires="p14">
           <p:contentPart p14:bwMode="auto" r:id="rId6">
             <p14:nvContentPartPr>
               <p14:cNvPr id="12" name="Ink 11">
@@ -25999,7 +26003,7 @@
             </p14:xfrm>
           </p:contentPart>
         </mc:Choice>
-        <mc:Fallback>
+        <mc:Fallback xmlns="">
           <p:pic>
             <p:nvPicPr>
               <p:cNvPr id="12" name="Ink 11">
@@ -26030,8 +26034,8 @@
           </p:pic>
         </mc:Fallback>
       </mc:AlternateContent>
-      <mc:AlternateContent xmlns:mc="http://schemas.openxmlformats.org/markup-compatibility/2006">
-        <mc:Choice xmlns:p14="http://schemas.microsoft.com/office/powerpoint/2010/main" Requires="p14">
+      <mc:AlternateContent xmlns:mc="http://schemas.openxmlformats.org/markup-compatibility/2006" xmlns:p14="http://schemas.microsoft.com/office/powerpoint/2010/main">
+        <mc:Choice Requires="p14">
           <p:contentPart p14:bwMode="auto" r:id="rId8">
             <p14:nvContentPartPr>
               <p14:cNvPr id="13" name="Ink 12">
@@ -26050,7 +26054,7 @@
             </p14:xfrm>
           </p:contentPart>
         </mc:Choice>
-        <mc:Fallback>
+        <mc:Fallback xmlns="">
           <p:pic>
             <p:nvPicPr>
               <p:cNvPr id="13" name="Ink 12">
@@ -26433,8 +26437,8 @@
           </a:p>
         </p:txBody>
       </p:sp>
-      <mc:AlternateContent xmlns:mc="http://schemas.openxmlformats.org/markup-compatibility/2006">
-        <mc:Choice xmlns:p14="http://schemas.microsoft.com/office/powerpoint/2010/main" Requires="p14">
+      <mc:AlternateContent xmlns:mc="http://schemas.openxmlformats.org/markup-compatibility/2006" xmlns:p14="http://schemas.microsoft.com/office/powerpoint/2010/main">
+        <mc:Choice Requires="p14">
           <p:contentPart p14:bwMode="auto" r:id="rId3">
             <p14:nvContentPartPr>
               <p14:cNvPr id="11" name="Ink 10">
@@ -26453,7 +26457,7 @@
             </p14:xfrm>
           </p:contentPart>
         </mc:Choice>
-        <mc:Fallback>
+        <mc:Fallback xmlns="">
           <p:pic>
             <p:nvPicPr>
               <p:cNvPr id="11" name="Ink 10">
@@ -26710,8 +26714,8 @@
           </a:p>
         </p:txBody>
       </p:sp>
-      <mc:AlternateContent xmlns:mc="http://schemas.openxmlformats.org/markup-compatibility/2006">
-        <mc:Choice xmlns:p14="http://schemas.microsoft.com/office/powerpoint/2010/main" Requires="p14">
+      <mc:AlternateContent xmlns:mc="http://schemas.openxmlformats.org/markup-compatibility/2006" xmlns:p14="http://schemas.microsoft.com/office/powerpoint/2010/main">
+        <mc:Choice Requires="p14">
           <p:contentPart p14:bwMode="auto" r:id="rId2">
             <p14:nvContentPartPr>
               <p14:cNvPr id="11" name="Ink 10">
@@ -26730,7 +26734,7 @@
             </p14:xfrm>
           </p:contentPart>
         </mc:Choice>
-        <mc:Fallback>
+        <mc:Fallback xmlns="">
           <p:pic>
             <p:nvPicPr>
               <p:cNvPr id="11" name="Ink 10">
@@ -26945,8 +26949,8 @@
           </a:p>
         </p:txBody>
       </p:sp>
-      <mc:AlternateContent xmlns:mc="http://schemas.openxmlformats.org/markup-compatibility/2006">
-        <mc:Choice xmlns:p14="http://schemas.microsoft.com/office/powerpoint/2010/main" Requires="p14">
+      <mc:AlternateContent xmlns:mc="http://schemas.openxmlformats.org/markup-compatibility/2006" xmlns:p14="http://schemas.microsoft.com/office/powerpoint/2010/main">
+        <mc:Choice Requires="p14">
           <p:contentPart p14:bwMode="auto" r:id="rId2">
             <p14:nvContentPartPr>
               <p14:cNvPr id="11" name="Ink 10">
@@ -26965,7 +26969,7 @@
             </p14:xfrm>
           </p:contentPart>
         </mc:Choice>
-        <mc:Fallback>
+        <mc:Fallback xmlns="">
           <p:pic>
             <p:nvPicPr>
               <p:cNvPr id="11" name="Ink 10">
@@ -27230,8 +27234,8 @@
           </a:p>
         </p:txBody>
       </p:sp>
-      <mc:AlternateContent xmlns:mc="http://schemas.openxmlformats.org/markup-compatibility/2006">
-        <mc:Choice xmlns:p14="http://schemas.microsoft.com/office/powerpoint/2010/main" Requires="p14">
+      <mc:AlternateContent xmlns:mc="http://schemas.openxmlformats.org/markup-compatibility/2006" xmlns:p14="http://schemas.microsoft.com/office/powerpoint/2010/main">
+        <mc:Choice Requires="p14">
           <p:contentPart p14:bwMode="auto" r:id="rId2">
             <p14:nvContentPartPr>
               <p14:cNvPr id="11" name="Ink 10">
@@ -27250,7 +27254,7 @@
             </p14:xfrm>
           </p:contentPart>
         </mc:Choice>
-        <mc:Fallback>
+        <mc:Fallback xmlns="">
           <p:pic>
             <p:nvPicPr>
               <p:cNvPr id="11" name="Ink 10">
@@ -28082,6 +28086,15 @@
 </file>
 
 <file path=customXml/item1.xml><?xml version="1.0" encoding="utf-8"?>
+<?mso-contentType ?>
+<FormTemplates xmlns="http://schemas.microsoft.com/sharepoint/v3/contenttype/forms">
+  <Display>DocumentLibraryForm</Display>
+  <Edit>DocumentLibraryForm</Edit>
+  <New>DocumentLibraryForm</New>
+</FormTemplates>
+</file>
+
+<file path=customXml/item2.xml><?xml version="1.0" encoding="utf-8"?>
 <p:properties xmlns:p="http://schemas.microsoft.com/office/2006/metadata/properties" xmlns:xsi="http://www.w3.org/2001/XMLSchema-instance" xmlns:pc="http://schemas.microsoft.com/office/infopath/2007/PartnerControls">
   <documentManagement>
     <TaxCatchAll xmlns="bc24777f-78b6-4f3c-a73a-d5fa08e4d537" xsi:nil="true"/>
@@ -28090,15 +28103,6 @@
     </lcf76f155ced4ddcb4097134ff3c332f>
   </documentManagement>
 </p:properties>
-</file>
-
-<file path=customXml/item2.xml><?xml version="1.0" encoding="utf-8"?>
-<?mso-contentType ?>
-<FormTemplates xmlns="http://schemas.microsoft.com/sharepoint/v3/contenttype/forms">
-  <Display>DocumentLibraryForm</Display>
-  <Edit>DocumentLibraryForm</Edit>
-  <New>DocumentLibraryForm</New>
-</FormTemplates>
 </file>
 
 <file path=customXml/item3.xml><?xml version="1.0" encoding="utf-8"?>
@@ -28357,6 +28361,14 @@
 </file>
 
 <file path=customXml/itemProps1.xml><?xml version="1.0" encoding="utf-8"?>
+<ds:datastoreItem xmlns:ds="http://schemas.openxmlformats.org/officeDocument/2006/customXml" ds:itemID="{4B6B7BE2-63AD-4C37-AC44-F0E4FC348E24}">
+  <ds:schemaRefs>
+    <ds:schemaRef ds:uri="http://schemas.microsoft.com/sharepoint/v3/contenttype/forms"/>
+  </ds:schemaRefs>
+</ds:datastoreItem>
+</file>
+
+<file path=customXml/itemProps2.xml><?xml version="1.0" encoding="utf-8"?>
 <ds:datastoreItem xmlns:ds="http://schemas.openxmlformats.org/officeDocument/2006/customXml" ds:itemID="{5626B806-0237-4942-A1FD-5C97285908C2}">
   <ds:schemaRefs>
     <ds:schemaRef ds:uri="http://schemas.microsoft.com/office/infopath/2007/PartnerControls"/>
@@ -28369,14 +28381,6 @@
     <ds:schemaRef ds:uri="http://purl.org/dc/dcmitype/"/>
     <ds:schemaRef ds:uri="bc24777f-78b6-4f3c-a73a-d5fa08e4d537"/>
     <ds:schemaRef ds:uri="http://www.w3.org/XML/1998/namespace"/>
-  </ds:schemaRefs>
-</ds:datastoreItem>
-</file>
-
-<file path=customXml/itemProps2.xml><?xml version="1.0" encoding="utf-8"?>
-<ds:datastoreItem xmlns:ds="http://schemas.openxmlformats.org/officeDocument/2006/customXml" ds:itemID="{4B6B7BE2-63AD-4C37-AC44-F0E4FC348E24}">
-  <ds:schemaRefs>
-    <ds:schemaRef ds:uri="http://schemas.microsoft.com/sharepoint/v3/contenttype/forms"/>
   </ds:schemaRefs>
 </ds:datastoreItem>
 </file>

</xml_diff>